<commit_message>
The skill joins the pipeline, and the pitch gets its contact line back
Verification of the 31 Aug state-of-play found two gaps between claim and
repo. The nightlife-culture-design skill was generated by a script nothing
ran: build.py had no skill step, so 'regenerated each build, fails on drift'
was aspiration. It is now step ten of the pipeline — parity (59/59) and the
live-type wordmark check run on every build and fail it.

And the email sweep deleted the closing slide's whole contact line along
with the old address, so a funding pitch ended with no way to reach its
author. Restored with the role address, right of the footer band.

postprocess_caps parks its temp file in _to_delete/ where the synced folder
forbids unlink.
</commit_message>
<xml_diff>
--- a/dist/UKDF_Fellowship_Proposal_Artists_Make_Great_Places_V2.pptx
+++ b/dist/UKDF_Fellowship_Proposal_Artists_Make_Great_Places_V2.pptx
@@ -2657,7 +2657,7 @@
       </p:grpSpPr>
       <p:pic>
         <p:nvPicPr>
-          <p:cNvPr id="3" name="Image 0" descr="/home/claude/build/adapters/powerpoint/wordmark-white.png">    </p:cNvPr>
+          <p:cNvPr id="3" name="Image 0" descr="/sessions/rcw-01v9q1qeaxsxzqswokqbtood/mnt/Nightlife Culture Design System/adapters/powerpoint/wordmark-white.png">    </p:cNvPr>
           <p:cNvPicPr>
             <a:picLocks noChangeAspect="1"/>
           </p:cNvPicPr>
@@ -3542,7 +3542,7 @@
       </p:sp>
       <p:pic>
         <p:nvPicPr>
-          <p:cNvPr id="24" name="Image 0" descr="/home/claude/build/adapters/powerpoint/wordmark-blue.png">    </p:cNvPr>
+          <p:cNvPr id="24" name="Image 0" descr="/sessions/rcw-01v9q1qeaxsxzqswokqbtood/mnt/Nightlife Culture Design System/adapters/powerpoint/wordmark-blue.png">    </p:cNvPr>
           <p:cNvPicPr>
             <a:picLocks noChangeAspect="1"/>
           </p:cNvPicPr>
@@ -3865,7 +3865,7 @@
       </p:sp>
       <p:pic>
         <p:nvPicPr>
-          <p:cNvPr id="6" name="Image 0" descr="/home/claude/build/adapters/powerpoint/wordmark-blue.png">    </p:cNvPr>
+          <p:cNvPr id="6" name="Image 0" descr="/sessions/rcw-01v9q1qeaxsxzqswokqbtood/mnt/Nightlife Culture Design System/adapters/powerpoint/wordmark-blue.png">    </p:cNvPr>
           <p:cNvPicPr>
             <a:picLocks noChangeAspect="1"/>
           </p:cNvPicPr>
@@ -4064,7 +4064,7 @@
       </p:sp>
       <p:pic>
         <p:nvPicPr>
-          <p:cNvPr id="6" name="Image 0" descr="/home/claude/build/adapters/powerpoint/wordmark-white.png">    </p:cNvPr>
+          <p:cNvPr id="6" name="Image 0" descr="/sessions/rcw-01v9q1qeaxsxzqswokqbtood/mnt/Nightlife Culture Design System/adapters/powerpoint/wordmark-white.png">    </p:cNvPr>
           <p:cNvPicPr>
             <a:picLocks noChangeAspect="1"/>
           </p:cNvPicPr>
@@ -4363,7 +4363,7 @@
       </p:sp>
       <p:pic>
         <p:nvPicPr>
-          <p:cNvPr id="6" name="Image 0" descr="/home/claude/build/adapters/powerpoint/wordmark-blue.png">    </p:cNvPr>
+          <p:cNvPr id="6" name="Image 0" descr="/sessions/rcw-01v9q1qeaxsxzqswokqbtood/mnt/Nightlife Culture Design System/adapters/powerpoint/wordmark-blue.png">    </p:cNvPr>
           <p:cNvPicPr>
             <a:picLocks noChangeAspect="1"/>
           </p:cNvPicPr>
@@ -4562,7 +4562,7 @@
       </p:sp>
       <p:pic>
         <p:nvPicPr>
-          <p:cNvPr id="6" name="Image 0" descr="/home/claude/build/adapters/powerpoint/wordmark-blue.png">    </p:cNvPr>
+          <p:cNvPr id="6" name="Image 0" descr="/sessions/rcw-01v9q1qeaxsxzqswokqbtood/mnt/Nightlife Culture Design System/adapters/powerpoint/wordmark-blue.png">    </p:cNvPr>
           <p:cNvPicPr>
             <a:picLocks noChangeAspect="1"/>
           </p:cNvPicPr>
@@ -4908,7 +4908,7 @@
       </p:sp>
       <p:pic>
         <p:nvPicPr>
-          <p:cNvPr id="10" name="Image 0" descr="/home/claude/build/adapters/powerpoint/wordmark-blue.png">    </p:cNvPr>
+          <p:cNvPr id="10" name="Image 0" descr="/sessions/rcw-01v9q1qeaxsxzqswokqbtood/mnt/Nightlife Culture Design System/adapters/powerpoint/wordmark-blue.png">    </p:cNvPr>
           <p:cNvPicPr>
             <a:picLocks noChangeAspect="1"/>
           </p:cNvPicPr>
@@ -5562,7 +5562,7 @@
       </p:sp>
       <p:pic>
         <p:nvPicPr>
-          <p:cNvPr id="19" name="Image 0" descr="/home/claude/build/adapters/powerpoint/wordmark-white.png">    </p:cNvPr>
+          <p:cNvPr id="19" name="Image 0" descr="/sessions/rcw-01v9q1qeaxsxzqswokqbtood/mnt/Nightlife Culture Design System/adapters/powerpoint/wordmark-white.png">    </p:cNvPr>
           <p:cNvPicPr>
             <a:picLocks noChangeAspect="1"/>
           </p:cNvPicPr>
@@ -5761,7 +5761,7 @@
       </p:sp>
       <p:pic>
         <p:nvPicPr>
-          <p:cNvPr id="6" name="Image 0" descr="/home/claude/build/adapters/powerpoint/wordmark-white.png">    </p:cNvPr>
+          <p:cNvPr id="6" name="Image 0" descr="/sessions/rcw-01v9q1qeaxsxzqswokqbtood/mnt/Nightlife Culture Design System/adapters/powerpoint/wordmark-white.png">    </p:cNvPr>
           <p:cNvPicPr>
             <a:picLocks noChangeAspect="1"/>
           </p:cNvPicPr>
@@ -6084,7 +6084,7 @@
       </p:sp>
       <p:pic>
         <p:nvPicPr>
-          <p:cNvPr id="6" name="Image 0" descr="/home/claude/build/adapters/powerpoint/wordmark-blue.png">    </p:cNvPr>
+          <p:cNvPr id="6" name="Image 0" descr="/sessions/rcw-01v9q1qeaxsxzqswokqbtood/mnt/Nightlife Culture Design System/adapters/powerpoint/wordmark-blue.png">    </p:cNvPr>
           <p:cNvPicPr>
             <a:picLocks noChangeAspect="1"/>
           </p:cNvPicPr>
@@ -6383,7 +6383,7 @@
       </p:sp>
       <p:pic>
         <p:nvPicPr>
-          <p:cNvPr id="6" name="Image 0" descr="/home/claude/build/adapters/powerpoint/wordmark-blue.png">    </p:cNvPr>
+          <p:cNvPr id="6" name="Image 0" descr="/sessions/rcw-01v9q1qeaxsxzqswokqbtood/mnt/Nightlife Culture Design System/adapters/powerpoint/wordmark-blue.png">    </p:cNvPr>
           <p:cNvPicPr>
             <a:picLocks noChangeAspect="1"/>
           </p:cNvPicPr>
@@ -6582,7 +6582,7 @@
       </p:sp>
       <p:pic>
         <p:nvPicPr>
-          <p:cNvPr id="6" name="Image 0" descr="/home/claude/build/adapters/powerpoint/wordmark-white.png">    </p:cNvPr>
+          <p:cNvPr id="6" name="Image 0" descr="/sessions/rcw-01v9q1qeaxsxzqswokqbtood/mnt/Nightlife Culture Design System/adapters/powerpoint/wordmark-white.png">    </p:cNvPr>
           <p:cNvPicPr>
             <a:picLocks noChangeAspect="1"/>
           </p:cNvPicPr>
@@ -6781,7 +6781,7 @@
       </p:sp>
       <p:pic>
         <p:nvPicPr>
-          <p:cNvPr id="6" name="Image 0" descr="/home/claude/build/adapters/powerpoint/wordmark-white.png">    </p:cNvPr>
+          <p:cNvPr id="6" name="Image 0" descr="/sessions/rcw-01v9q1qeaxsxzqswokqbtood/mnt/Nightlife Culture Design System/adapters/powerpoint/wordmark-white.png">    </p:cNvPr>
           <p:cNvPicPr>
             <a:picLocks noChangeAspect="1"/>
           </p:cNvPicPr>
@@ -7143,7 +7143,7 @@
       </p:sp>
       <p:pic>
         <p:nvPicPr>
-          <p:cNvPr id="7" name="Image 0" descr="/home/claude/build/adapters/powerpoint/wordmark-white.png">    </p:cNvPr>
+          <p:cNvPr id="7" name="Image 0" descr="/sessions/rcw-01v9q1qeaxsxzqswokqbtood/mnt/Nightlife Culture Design System/adapters/powerpoint/wordmark-white.png">    </p:cNvPr>
           <p:cNvPicPr>
             <a:picLocks noChangeAspect="1"/>
           </p:cNvPicPr>
@@ -7165,6 +7165,45 @@
           </a:prstGeom>
         </p:spPr>
       </p:pic>
+      <p:sp>
+        <p:nvSpPr>
+          <p:cNvPr id="8" name="Text 4"/>
+          <p:cNvSpPr/>
+          <p:nvPr/>
+        </p:nvSpPr>
+        <p:spPr>
+          <a:xfrm>
+            <a:off x="5699471" y="6199655"/>
+            <a:ext cx="5852160" cy="320040"/>
+          </a:xfrm>
+          <a:prstGeom prst="rect">
+            <a:avLst/>
+          </a:prstGeom>
+          <a:noFill/>
+          <a:ln/>
+        </p:spPr>
+        <p:txBody>
+          <a:bodyPr wrap="square" lIns="0" tIns="0" rIns="0" bIns="0" rtlCol="0" anchor="ctr"/>
+          <a:lstStyle/>
+          <a:p>
+            <a:pPr algn="r" indent="0" marL="0">
+              <a:buNone/>
+            </a:pPr>
+            <a:r>
+              <a:rPr lang="en-US" sz="1400" b="1" dirty="0">
+                <a:solidFill>
+                  <a:srgbClr val="FFFFFF"/>
+                </a:solidFill>
+                <a:latin typeface="Archivo" pitchFamily="34" charset="0"/>
+                <a:ea typeface="Archivo" pitchFamily="34" charset="-122"/>
+                <a:cs typeface="Archivo" pitchFamily="34" charset="-120"/>
+              </a:rPr>
+              <a:t>Carly Heath · Nightlife Culture · studio@nightlifeculture.co.uk</a:t>
+            </a:r>
+            <a:endParaRPr lang="en-US" sz="1400" dirty="0"/>
+          </a:p>
+        </p:txBody>
+      </p:sp>
     </p:spTree>
   </p:cSld>
   <p:clrMapOvr>
@@ -7303,7 +7342,7 @@
       </p:sp>
       <p:pic>
         <p:nvPicPr>
-          <p:cNvPr id="6" name="Image 0" descr="/home/claude/build/adapters/powerpoint/wordmark-white.png">    </p:cNvPr>
+          <p:cNvPr id="6" name="Image 0" descr="/sessions/rcw-01v9q1qeaxsxzqswokqbtood/mnt/Nightlife Culture Design System/adapters/powerpoint/wordmark-white.png">    </p:cNvPr>
           <p:cNvPicPr>
             <a:picLocks noChangeAspect="1"/>
           </p:cNvPicPr>
@@ -7695,7 +7734,7 @@
       </p:sp>
       <p:pic>
         <p:nvPicPr>
-          <p:cNvPr id="12" name="Image 0" descr="/home/claude/build/adapters/powerpoint/wordmark-blue.png">    </p:cNvPr>
+          <p:cNvPr id="12" name="Image 0" descr="/sessions/rcw-01v9q1qeaxsxzqswokqbtood/mnt/Nightlife Culture Design System/adapters/powerpoint/wordmark-blue.png">    </p:cNvPr>
           <p:cNvPicPr>
             <a:picLocks noChangeAspect="1"/>
           </p:cNvPicPr>
@@ -7894,7 +7933,7 @@
       </p:sp>
       <p:pic>
         <p:nvPicPr>
-          <p:cNvPr id="6" name="Image 0" descr="/home/claude/build/adapters/powerpoint/wordmark-white.png">    </p:cNvPr>
+          <p:cNvPr id="6" name="Image 0" descr="/sessions/rcw-01v9q1qeaxsxzqswokqbtood/mnt/Nightlife Culture Design System/adapters/powerpoint/wordmark-white.png">    </p:cNvPr>
           <p:cNvPicPr>
             <a:picLocks noChangeAspect="1"/>
           </p:cNvPicPr>
@@ -8169,7 +8208,7 @@
       </p:sp>
       <p:pic>
         <p:nvPicPr>
-          <p:cNvPr id="6" name="Image 0" descr="/home/claude/build/adapters/powerpoint/wordmark-blue.png">    </p:cNvPr>
+          <p:cNvPr id="6" name="Image 0" descr="/sessions/rcw-01v9q1qeaxsxzqswokqbtood/mnt/Nightlife Culture Design System/adapters/powerpoint/wordmark-blue.png">    </p:cNvPr>
           <p:cNvPicPr>
             <a:picLocks noChangeAspect="1"/>
           </p:cNvPicPr>
@@ -8368,7 +8407,7 @@
       </p:sp>
       <p:pic>
         <p:nvPicPr>
-          <p:cNvPr id="6" name="Image 0" descr="/home/claude/build/adapters/powerpoint/wordmark-white.png">    </p:cNvPr>
+          <p:cNvPr id="6" name="Image 0" descr="/sessions/rcw-01v9q1qeaxsxzqswokqbtood/mnt/Nightlife Culture Design System/adapters/powerpoint/wordmark-white.png">    </p:cNvPr>
           <p:cNvPicPr>
             <a:picLocks noChangeAspect="1"/>
           </p:cNvPicPr>
@@ -8609,7 +8648,7 @@
       </p:sp>
       <p:pic>
         <p:nvPicPr>
-          <p:cNvPr id="7" name="Image 0" descr="/home/claude/build/adapters/powerpoint/wordmark-blue.png">    </p:cNvPr>
+          <p:cNvPr id="7" name="Image 0" descr="/sessions/rcw-01v9q1qeaxsxzqswokqbtood/mnt/Nightlife Culture Design System/adapters/powerpoint/wordmark-blue.png">    </p:cNvPr>
           <p:cNvPicPr>
             <a:picLocks noChangeAspect="1"/>
           </p:cNvPicPr>
@@ -8884,7 +8923,7 @@
       </p:sp>
       <p:pic>
         <p:nvPicPr>
-          <p:cNvPr id="6" name="Image 0" descr="/home/claude/build/adapters/powerpoint/wordmark-white.png">    </p:cNvPr>
+          <p:cNvPr id="6" name="Image 0" descr="/sessions/rcw-01v9q1qeaxsxzqswokqbtood/mnt/Nightlife Culture Design System/adapters/powerpoint/wordmark-white.png">    </p:cNvPr>
           <p:cNvPicPr>
             <a:picLocks noChangeAspect="1"/>
           </p:cNvPicPr>

</xml_diff>